<commit_message>
Update all Sprouts AI work sample files
Co-Authored-By: Claude Sonnet 4.6 <noreply@anthropic.com>
</commit_message>
<xml_diff>
--- a/public/work-samples/Sprouts_AI_Internal_PrepDeck.pptx
+++ b/public/work-samples/Sprouts_AI_Internal_PrepDeck.pptx
@@ -1248,6 +1248,10 @@
             <a:prstDash val="solid"/>
           </a:ln>
         </p:spPr>
+        <p:txBody>
+          <a:bodyPr/>
+          <a:p/>
+        </p:txBody>
       </p:sp>
       <p:sp>
         <p:nvSpPr>
@@ -1277,6 +1281,10 @@
             <a:prstDash val="solid"/>
           </a:ln>
         </p:spPr>
+        <p:txBody>
+          <a:bodyPr/>
+          <a:p/>
+        </p:txBody>
       </p:sp>
       <p:sp>
         <p:nvSpPr>
@@ -1306,6 +1314,10 @@
             <a:prstDash val="solid"/>
           </a:ln>
         </p:spPr>
+        <p:txBody>
+          <a:bodyPr/>
+          <a:p/>
+        </p:txBody>
       </p:sp>
       <p:sp>
         <p:nvSpPr>
@@ -1439,6 +1451,10 @@
             <a:prstDash val="solid"/>
           </a:ln>
         </p:spPr>
+        <p:txBody>
+          <a:bodyPr/>
+          <a:p/>
+        </p:txBody>
       </p:sp>
       <p:sp>
         <p:nvSpPr>
@@ -1526,7 +1542,7 @@
                   <a:srgbClr val="8AADCC"/>
                 </a:solidFill>
               </a:rPr>
-              <a:t>focuses on decisions — not coordination.</a:t>
+              <a:t>focuses on decisions - not coordination.</a:t>
             </a:r>
             <a:endParaRPr lang="en-US" sz="1300" dirty="0"/>
           </a:p>
@@ -1562,6 +1578,10 @@
             <a:prstDash val="solid"/>
           </a:ln>
         </p:spPr>
+        <p:txBody>
+          <a:bodyPr/>
+          <a:p/>
+        </p:txBody>
       </p:sp>
       <p:sp>
         <p:nvSpPr>
@@ -1701,6 +1721,10 @@
             <a:prstDash val="solid"/>
           </a:ln>
         </p:spPr>
+        <p:txBody>
+          <a:bodyPr/>
+          <a:p/>
+        </p:txBody>
       </p:sp>
       <p:sp>
         <p:nvSpPr>
@@ -1840,6 +1864,10 @@
             <a:prstDash val="solid"/>
           </a:ln>
         </p:spPr>
+        <p:txBody>
+          <a:bodyPr/>
+          <a:p/>
+        </p:txBody>
       </p:sp>
       <p:sp>
         <p:nvSpPr>
@@ -1979,7 +2007,7 @@
                   <a:srgbClr val="666666"/>
                 </a:solidFill>
               </a:rPr>
-              <a:t>For Internal Use Only  ·  PMM: Kitty Rastogi  ·  2024</a:t>
+              <a:t>For Internal Use Only</a:t>
             </a:r>
             <a:endParaRPr lang="en-US" sz="800" dirty="0"/>
           </a:p>
@@ -2034,6 +2062,10 @@
             <a:prstDash val="solid"/>
           </a:ln>
         </p:spPr>
+        <p:txBody>
+          <a:bodyPr/>
+          <a:p/>
+        </p:txBody>
       </p:sp>
       <p:sp>
         <p:nvSpPr>
@@ -2169,6 +2201,10 @@
             <a:prstDash val="solid"/>
           </a:ln>
         </p:spPr>
+        <p:txBody>
+          <a:bodyPr/>
+          <a:p/>
+        </p:txBody>
       </p:sp>
       <p:sp>
         <p:nvSpPr>
@@ -2232,6 +2268,10 @@
             <a:prstDash val="solid"/>
           </a:ln>
         </p:spPr>
+        <p:txBody>
+          <a:bodyPr/>
+          <a:p/>
+        </p:txBody>
       </p:sp>
       <p:sp>
         <p:nvSpPr>
@@ -2257,6 +2297,10 @@
             <a:prstDash val="solid"/>
           </a:ln>
         </p:spPr>
+        <p:txBody>
+          <a:bodyPr/>
+          <a:p/>
+        </p:txBody>
       </p:sp>
       <p:sp>
         <p:nvSpPr>
@@ -2284,6 +2328,10 @@
             <a:prstDash val="solid"/>
           </a:ln>
         </p:spPr>
+        <p:txBody>
+          <a:bodyPr/>
+          <a:p/>
+        </p:txBody>
       </p:sp>
       <p:sp>
         <p:nvSpPr>
@@ -2740,6 +2788,10 @@
             <a:prstDash val="solid"/>
           </a:ln>
         </p:spPr>
+        <p:txBody>
+          <a:bodyPr/>
+          <a:p/>
+        </p:txBody>
       </p:sp>
       <p:sp>
         <p:nvSpPr>
@@ -2765,6 +2817,10 @@
             <a:prstDash val="solid"/>
           </a:ln>
         </p:spPr>
+        <p:txBody>
+          <a:bodyPr/>
+          <a:p/>
+        </p:txBody>
       </p:sp>
       <p:sp>
         <p:nvSpPr>
@@ -2792,6 +2848,10 @@
             <a:prstDash val="solid"/>
           </a:ln>
         </p:spPr>
+        <p:txBody>
+          <a:bodyPr/>
+          <a:p/>
+        </p:txBody>
       </p:sp>
       <p:sp>
         <p:nvSpPr>
@@ -3248,6 +3308,10 @@
             <a:prstDash val="solid"/>
           </a:ln>
         </p:spPr>
+        <p:txBody>
+          <a:bodyPr/>
+          <a:p/>
+        </p:txBody>
       </p:sp>
       <p:sp>
         <p:nvSpPr>
@@ -3273,6 +3337,10 @@
             <a:prstDash val="solid"/>
           </a:ln>
         </p:spPr>
+        <p:txBody>
+          <a:bodyPr/>
+          <a:p/>
+        </p:txBody>
       </p:sp>
       <p:sp>
         <p:nvSpPr>
@@ -3300,6 +3368,10 @@
             <a:prstDash val="solid"/>
           </a:ln>
         </p:spPr>
+        <p:txBody>
+          <a:bodyPr/>
+          <a:p/>
+        </p:txBody>
       </p:sp>
       <p:sp>
         <p:nvSpPr>
@@ -3779,6 +3851,10 @@
             <a:prstDash val="solid"/>
           </a:ln>
         </p:spPr>
+        <p:txBody>
+          <a:bodyPr/>
+          <a:p/>
+        </p:txBody>
       </p:sp>
       <p:sp>
         <p:nvSpPr>
@@ -3914,6 +3990,10 @@
             <a:prstDash val="solid"/>
           </a:ln>
         </p:spPr>
+        <p:txBody>
+          <a:bodyPr/>
+          <a:p/>
+        </p:txBody>
       </p:sp>
       <p:sp>
         <p:nvSpPr>
@@ -4030,6 +4110,10 @@
             <a:prstDash val="solid"/>
           </a:ln>
         </p:spPr>
+        <p:txBody>
+          <a:bodyPr/>
+          <a:p/>
+        </p:txBody>
       </p:sp>
       <p:sp>
         <p:nvSpPr>
@@ -4168,6 +4252,10 @@
             <a:prstDash val="solid"/>
           </a:ln>
         </p:spPr>
+        <p:txBody>
+          <a:bodyPr/>
+          <a:p/>
+        </p:txBody>
       </p:sp>
       <p:sp>
         <p:nvSpPr>
@@ -4323,6 +4411,10 @@
             <a:prstDash val="solid"/>
           </a:ln>
         </p:spPr>
+        <p:txBody>
+          <a:bodyPr/>
+          <a:p/>
+        </p:txBody>
       </p:sp>
       <p:sp>
         <p:nvSpPr>
@@ -4478,6 +4570,10 @@
             <a:prstDash val="solid"/>
           </a:ln>
         </p:spPr>
+        <p:txBody>
+          <a:bodyPr/>
+          <a:p/>
+        </p:txBody>
       </p:sp>
       <p:sp>
         <p:nvSpPr>
@@ -4631,6 +4727,10 @@
             <a:prstDash val="solid"/>
           </a:ln>
         </p:spPr>
+        <p:txBody>
+          <a:bodyPr/>
+          <a:p/>
+        </p:txBody>
       </p:sp>
       <p:sp>
         <p:nvSpPr>
@@ -4684,6 +4784,10 @@
             <a:prstDash val="solid"/>
           </a:ln>
         </p:spPr>
+        <p:txBody>
+          <a:bodyPr/>
+          <a:p/>
+        </p:txBody>
       </p:sp>
       <p:sp>
         <p:nvSpPr>
@@ -4745,6 +4849,10 @@
             <a:prstDash val="solid"/>
           </a:ln>
         </p:spPr>
+        <p:txBody>
+          <a:bodyPr/>
+          <a:p/>
+        </p:txBody>
       </p:sp>
       <p:sp>
         <p:nvSpPr>
@@ -4806,6 +4914,10 @@
             <a:prstDash val="solid"/>
           </a:ln>
         </p:spPr>
+        <p:txBody>
+          <a:bodyPr/>
+          <a:p/>
+        </p:txBody>
       </p:sp>
       <p:sp>
         <p:nvSpPr>
@@ -4867,6 +4979,10 @@
             <a:prstDash val="solid"/>
           </a:ln>
         </p:spPr>
+        <p:txBody>
+          <a:bodyPr/>
+          <a:p/>
+        </p:txBody>
       </p:sp>
       <p:sp>
         <p:nvSpPr>
@@ -4928,6 +5044,10 @@
             <a:prstDash val="solid"/>
           </a:ln>
         </p:spPr>
+        <p:txBody>
+          <a:bodyPr/>
+          <a:p/>
+        </p:txBody>
       </p:sp>
       <p:sp>
         <p:nvSpPr>
@@ -4989,6 +5109,10 @@
             <a:prstDash val="solid"/>
           </a:ln>
         </p:spPr>
+        <p:txBody>
+          <a:bodyPr/>
+          <a:p/>
+        </p:txBody>
       </p:sp>
       <p:sp>
         <p:nvSpPr>
@@ -5050,6 +5174,10 @@
             <a:prstDash val="solid"/>
           </a:ln>
         </p:spPr>
+        <p:txBody>
+          <a:bodyPr/>
+          <a:p/>
+        </p:txBody>
       </p:sp>
       <p:sp>
         <p:nvSpPr>
@@ -5111,6 +5239,10 @@
             <a:prstDash val="solid"/>
           </a:ln>
         </p:spPr>
+        <p:txBody>
+          <a:bodyPr/>
+          <a:p/>
+        </p:txBody>
       </p:sp>
       <p:sp>
         <p:nvSpPr>
@@ -5172,6 +5304,10 @@
             <a:prstDash val="solid"/>
           </a:ln>
         </p:spPr>
+        <p:txBody>
+          <a:bodyPr/>
+          <a:p/>
+        </p:txBody>
       </p:sp>
       <p:sp>
         <p:nvSpPr>
@@ -5233,6 +5369,10 @@
             <a:prstDash val="solid"/>
           </a:ln>
         </p:spPr>
+        <p:txBody>
+          <a:bodyPr/>
+          <a:p/>
+        </p:txBody>
       </p:sp>
       <p:sp>
         <p:nvSpPr>
@@ -5294,6 +5434,10 @@
             <a:prstDash val="solid"/>
           </a:ln>
         </p:spPr>
+        <p:txBody>
+          <a:bodyPr/>
+          <a:p/>
+        </p:txBody>
       </p:sp>
       <p:sp>
         <p:nvSpPr>
@@ -5355,6 +5499,10 @@
             <a:prstDash val="solid"/>
           </a:ln>
         </p:spPr>
+        <p:txBody>
+          <a:bodyPr/>
+          <a:p/>
+        </p:txBody>
       </p:sp>
       <p:sp>
         <p:nvSpPr>
@@ -5416,6 +5564,10 @@
             <a:prstDash val="solid"/>
           </a:ln>
         </p:spPr>
+        <p:txBody>
+          <a:bodyPr/>
+          <a:p/>
+        </p:txBody>
       </p:sp>
       <p:sp>
         <p:nvSpPr>
@@ -5477,6 +5629,10 @@
             <a:prstDash val="solid"/>
           </a:ln>
         </p:spPr>
+        <p:txBody>
+          <a:bodyPr/>
+          <a:p/>
+        </p:txBody>
       </p:sp>
       <p:sp>
         <p:nvSpPr>
@@ -5538,6 +5694,10 @@
             <a:prstDash val="solid"/>
           </a:ln>
         </p:spPr>
+        <p:txBody>
+          <a:bodyPr/>
+          <a:p/>
+        </p:txBody>
       </p:sp>
       <p:sp>
         <p:nvSpPr>
@@ -5599,6 +5759,10 @@
             <a:prstDash val="solid"/>
           </a:ln>
         </p:spPr>
+        <p:txBody>
+          <a:bodyPr/>
+          <a:p/>
+        </p:txBody>
       </p:sp>
       <p:sp>
         <p:nvSpPr>
@@ -5660,6 +5824,10 @@
             <a:prstDash val="solid"/>
           </a:ln>
         </p:spPr>
+        <p:txBody>
+          <a:bodyPr/>
+          <a:p/>
+        </p:txBody>
       </p:sp>
       <p:sp>
         <p:nvSpPr>
@@ -5721,6 +5889,10 @@
             <a:prstDash val="solid"/>
           </a:ln>
         </p:spPr>
+        <p:txBody>
+          <a:bodyPr/>
+          <a:p/>
+        </p:txBody>
       </p:sp>
       <p:sp>
         <p:nvSpPr>
@@ -5782,6 +5954,10 @@
             <a:prstDash val="solid"/>
           </a:ln>
         </p:spPr>
+        <p:txBody>
+          <a:bodyPr/>
+          <a:p/>
+        </p:txBody>
       </p:sp>
       <p:sp>
         <p:nvSpPr>
@@ -5868,6 +6044,10 @@
             <a:prstDash val="solid"/>
           </a:ln>
         </p:spPr>
+        <p:txBody>
+          <a:bodyPr/>
+          <a:p/>
+        </p:txBody>
       </p:sp>
       <p:sp>
         <p:nvSpPr>
@@ -6075,6 +6255,10 @@
             <a:prstDash val="solid"/>
           </a:ln>
         </p:spPr>
+        <p:txBody>
+          <a:bodyPr/>
+          <a:p/>
+        </p:txBody>
       </p:sp>
       <p:sp>
         <p:nvSpPr>
@@ -6100,6 +6284,10 @@
             <a:prstDash val="solid"/>
           </a:ln>
         </p:spPr>
+        <p:txBody>
+          <a:bodyPr/>
+          <a:p/>
+        </p:txBody>
       </p:sp>
       <p:sp>
         <p:nvSpPr>
@@ -6238,6 +6426,10 @@
             <a:prstDash val="solid"/>
           </a:ln>
         </p:spPr>
+        <p:txBody>
+          <a:bodyPr/>
+          <a:p/>
+        </p:txBody>
       </p:sp>
       <p:sp>
         <p:nvSpPr>
@@ -6263,6 +6455,10 @@
             <a:prstDash val="solid"/>
           </a:ln>
         </p:spPr>
+        <p:txBody>
+          <a:bodyPr/>
+          <a:p/>
+        </p:txBody>
       </p:sp>
       <p:sp>
         <p:nvSpPr>
@@ -6401,6 +6597,10 @@
             <a:prstDash val="solid"/>
           </a:ln>
         </p:spPr>
+        <p:txBody>
+          <a:bodyPr/>
+          <a:p/>
+        </p:txBody>
       </p:sp>
       <p:sp>
         <p:nvSpPr>
@@ -6426,6 +6626,10 @@
             <a:prstDash val="solid"/>
           </a:ln>
         </p:spPr>
+        <p:txBody>
+          <a:bodyPr/>
+          <a:p/>
+        </p:txBody>
       </p:sp>
       <p:sp>
         <p:nvSpPr>
@@ -6564,6 +6768,10 @@
             <a:prstDash val="solid"/>
           </a:ln>
         </p:spPr>
+        <p:txBody>
+          <a:bodyPr/>
+          <a:p/>
+        </p:txBody>
       </p:sp>
       <p:sp>
         <p:nvSpPr>
@@ -6589,6 +6797,10 @@
             <a:prstDash val="solid"/>
           </a:ln>
         </p:spPr>
+        <p:txBody>
+          <a:bodyPr/>
+          <a:p/>
+        </p:txBody>
       </p:sp>
       <p:sp>
         <p:nvSpPr>
@@ -6799,6 +7011,10 @@
             <a:prstDash val="solid"/>
           </a:ln>
         </p:spPr>
+        <p:txBody>
+          <a:bodyPr/>
+          <a:p/>
+        </p:txBody>
       </p:sp>
       <p:sp>
         <p:nvSpPr>
@@ -6824,6 +7040,10 @@
             <a:prstDash val="solid"/>
           </a:ln>
         </p:spPr>
+        <p:txBody>
+          <a:bodyPr/>
+          <a:p/>
+        </p:txBody>
       </p:sp>
       <p:sp>
         <p:nvSpPr>
@@ -6962,6 +7182,10 @@
             <a:prstDash val="solid"/>
           </a:ln>
         </p:spPr>
+        <p:txBody>
+          <a:bodyPr/>
+          <a:p/>
+        </p:txBody>
       </p:sp>
       <p:sp>
         <p:nvSpPr>
@@ -6987,6 +7211,10 @@
             <a:prstDash val="solid"/>
           </a:ln>
         </p:spPr>
+        <p:txBody>
+          <a:bodyPr/>
+          <a:p/>
+        </p:txBody>
       </p:sp>
       <p:sp>
         <p:nvSpPr>
@@ -7125,6 +7353,10 @@
             <a:prstDash val="solid"/>
           </a:ln>
         </p:spPr>
+        <p:txBody>
+          <a:bodyPr/>
+          <a:p/>
+        </p:txBody>
       </p:sp>
       <p:sp>
         <p:nvSpPr>
@@ -7150,6 +7382,10 @@
             <a:prstDash val="solid"/>
           </a:ln>
         </p:spPr>
+        <p:txBody>
+          <a:bodyPr/>
+          <a:p/>
+        </p:txBody>
       </p:sp>
       <p:sp>
         <p:nvSpPr>
@@ -7288,6 +7524,10 @@
             <a:prstDash val="solid"/>
           </a:ln>
         </p:spPr>
+        <p:txBody>
+          <a:bodyPr/>
+          <a:p/>
+        </p:txBody>
       </p:sp>
       <p:sp>
         <p:nvSpPr>
@@ -7313,6 +7553,10 @@
             <a:prstDash val="solid"/>
           </a:ln>
         </p:spPr>
+        <p:txBody>
+          <a:bodyPr/>
+          <a:p/>
+        </p:txBody>
       </p:sp>
       <p:sp>
         <p:nvSpPr>
@@ -7451,6 +7695,10 @@
             <a:prstDash val="solid"/>
           </a:ln>
         </p:spPr>
+        <p:txBody>
+          <a:bodyPr/>
+          <a:p/>
+        </p:txBody>
       </p:sp>
       <p:sp>
         <p:nvSpPr>
@@ -7476,6 +7724,10 @@
             <a:prstDash val="solid"/>
           </a:ln>
         </p:spPr>
+        <p:txBody>
+          <a:bodyPr/>
+          <a:p/>
+        </p:txBody>
       </p:sp>
       <p:sp>
         <p:nvSpPr>
@@ -7637,6 +7889,10 @@
             <a:prstDash val="solid"/>
           </a:ln>
         </p:spPr>
+        <p:txBody>
+          <a:bodyPr/>
+          <a:p/>
+        </p:txBody>
       </p:sp>
       <p:sp>
         <p:nvSpPr>
@@ -7808,6 +8064,10 @@
             <a:prstDash val="solid"/>
           </a:ln>
         </p:spPr>
+        <p:txBody>
+          <a:bodyPr/>
+          <a:p/>
+        </p:txBody>
       </p:sp>
       <p:sp>
         <p:nvSpPr>
@@ -7835,6 +8095,10 @@
             <a:prstDash val="solid"/>
           </a:ln>
         </p:spPr>
+        <p:txBody>
+          <a:bodyPr/>
+          <a:p/>
+        </p:txBody>
       </p:sp>
       <p:sp>
         <p:nvSpPr>
@@ -7905,7 +8169,7 @@
                   <a:srgbClr val="222222"/>
                 </a:solidFill>
               </a:rPr>
-              <a:t>Sprouts integrates with Greenhouse — we're the automation layer on top. You keep your ATS, we eliminate the coordination your team is doing manually.</a:t>
+              <a:t>Sprouts integrates with Greenhouse - we're the automation layer on top. You keep your ATS, we eliminate the coordination your team is doing manually.</a:t>
             </a:r>
             <a:endParaRPr lang="en-US" sz="950" dirty="0"/>
           </a:p>
@@ -7937,6 +8201,10 @@
             <a:prstDash val="solid"/>
           </a:ln>
         </p:spPr>
+        <p:txBody>
+          <a:bodyPr/>
+          <a:p/>
+        </p:txBody>
       </p:sp>
       <p:sp>
         <p:nvSpPr>
@@ -7964,6 +8232,10 @@
             <a:prstDash val="solid"/>
           </a:ln>
         </p:spPr>
+        <p:txBody>
+          <a:bodyPr/>
+          <a:p/>
+        </p:txBody>
       </p:sp>
       <p:sp>
         <p:nvSpPr>
@@ -8066,6 +8338,10 @@
             <a:prstDash val="solid"/>
           </a:ln>
         </p:spPr>
+        <p:txBody>
+          <a:bodyPr/>
+          <a:p/>
+        </p:txBody>
       </p:sp>
       <p:sp>
         <p:nvSpPr>
@@ -8093,6 +8369,10 @@
             <a:prstDash val="solid"/>
           </a:ln>
         </p:spPr>
+        <p:txBody>
+          <a:bodyPr/>
+          <a:p/>
+        </p:txBody>
       </p:sp>
       <p:sp>
         <p:nvSpPr>
@@ -8124,7 +8404,7 @@
                   <a:srgbClr val="C0392B"/>
                 </a:solidFill>
               </a:rPr>
-              <a:t>"You're an early startup — is this ready?"</a:t>
+              <a:t>"You're an early startup - is this ready?"</a:t>
             </a:r>
             <a:endParaRPr lang="en-US" sz="1000" dirty="0"/>
           </a:p>
@@ -8195,6 +8475,10 @@
             <a:prstDash val="solid"/>
           </a:ln>
         </p:spPr>
+        <p:txBody>
+          <a:bodyPr/>
+          <a:p/>
+        </p:txBody>
       </p:sp>
       <p:sp>
         <p:nvSpPr>
@@ -8222,6 +8506,10 @@
             <a:prstDash val="solid"/>
           </a:ln>
         </p:spPr>
+        <p:txBody>
+          <a:bodyPr/>
+          <a:p/>
+        </p:txBody>
       </p:sp>
       <p:sp>
         <p:nvSpPr>
@@ -8292,7 +8580,7 @@
                   <a:srgbClr val="222222"/>
                 </a:solidFill>
               </a:rPr>
-              <a:t>Ashby speeds up tasks. Sprouts removes the tasks. That's 10+ hours/week back — not 10% faster on the same work.</a:t>
+              <a:t>Ashby speeds up tasks. Sprouts removes the tasks. That's 10+ hours/week back - not 10% faster on the same work.</a:t>
             </a:r>
             <a:endParaRPr lang="en-US" sz="950" dirty="0"/>
           </a:p>
@@ -8328,7 +8616,7 @@
                   <a:srgbClr val="0D7377"/>
                 </a:solidFill>
               </a:rPr>
-              <a:t>QUALIFIED DEAL — ALL 4 MUST BE TRUE</a:t>
+              <a:t>QUALIFIED DEAL - ALL 4 MUST BE TRUE</a:t>
             </a:r>
             <a:endParaRPr lang="en-US" sz="850" dirty="0"/>
           </a:p>
@@ -8360,6 +8648,10 @@
             <a:prstDash val="solid"/>
           </a:ln>
         </p:spPr>
+        <p:txBody>
+          <a:bodyPr/>
+          <a:p/>
+        </p:txBody>
       </p:sp>
       <p:sp>
         <p:nvSpPr>
@@ -8434,6 +8726,10 @@
             <a:prstDash val="solid"/>
           </a:ln>
         </p:spPr>
+        <p:txBody>
+          <a:bodyPr/>
+          <a:p/>
+        </p:txBody>
       </p:sp>
       <p:sp>
         <p:nvSpPr>
@@ -8508,6 +8804,10 @@
             <a:prstDash val="solid"/>
           </a:ln>
         </p:spPr>
+        <p:txBody>
+          <a:bodyPr/>
+          <a:p/>
+        </p:txBody>
       </p:sp>
       <p:sp>
         <p:nvSpPr>
@@ -8582,6 +8882,10 @@
             <a:prstDash val="solid"/>
           </a:ln>
         </p:spPr>
+        <p:txBody>
+          <a:bodyPr/>
+          <a:p/>
+        </p:txBody>
       </p:sp>
       <p:sp>
         <p:nvSpPr>
@@ -8692,6 +8996,10 @@
             <a:prstDash val="solid"/>
           </a:ln>
         </p:spPr>
+        <p:txBody>
+          <a:bodyPr/>
+          <a:p/>
+        </p:txBody>
       </p:sp>
       <p:sp>
         <p:nvSpPr>
@@ -8814,7 +9122,7 @@
                   <a:srgbClr val="666666"/>
                 </a:solidFill>
               </a:rPr>
-              <a:t>Sprouts AI  ·  Internal Sales Prep Deck  ·  PMM: Kitty Rastogi  ·  2024</a:t>
+              <a:t>Sprouts AI · Internal Sales Prep Deck</a:t>
             </a:r>
             <a:endParaRPr lang="en-US" sz="800" dirty="0"/>
           </a:p>

</xml_diff>